<commit_message>
docs(report): animate the cover slide and tighten the speaker notes
No change to D, U, nu, mesh counts or time steps.

Co-Authored-By: Claude Opus 5.5 <noreply@anthropic.com>
</commit_message>
<xml_diff>
--- a/report/presentation.pptx
+++ b/report/presentation.pptx
@@ -116,30 +116,30 @@
   <p:extLst>
     <p:ext uri="{521415D9-36F7-43E2-AB2F-B90AF26B5E84}">
       <p14:sectionLst xmlns:p14="http://schemas.microsoft.com/office/powerpoint/2010/main">
-        <p14:section name="Introduction" id="{c678cc22-c1c0-e9e3-e493-96f08861908e}">
+        <p14:section name="Introduction" id="{55144bba-e0f8-c9e2-e020-71ff0b4934ed}">
           <p14:sldIdLst>
             <p14:sldId id="256"/>
             <p14:sldId id="257"/>
           </p14:sldIdLst>
         </p14:section>
-        <p14:section name="What was done" id="{f232c134-7dde-e1f6-dc8f-f2a205399830}">
+        <p14:section name="What was done" id="{9a357aaa-68b4-ca1b-5d7d-7a8458dff4c3}">
           <p14:sldIdLst>
             <p14:sldId id="258"/>
           </p14:sldIdLst>
         </p14:section>
-        <p14:section name="Results" id="{067d8ed1-ad3c-3db4-f977-06ec0f254712}">
+        <p14:section name="Results" id="{ed899025-ed04-ddab-61ec-b0ebcb7c396b}">
           <p14:sldIdLst>
             <p14:sldId id="259"/>
             <p14:sldId id="260"/>
           </p14:sldIdLst>
         </p14:section>
-        <p14:section name="Can we trust it" id="{ec082147-de56-231f-6816-bbf15877d702}">
+        <p14:section name="Can we trust it" id="{c8a9abf8-6b0b-49b7-b796-5890d99694e8}">
           <p14:sldIdLst>
             <p14:sldId id="261"/>
             <p14:sldId id="262"/>
           </p14:sldIdLst>
         </p14:section>
-        <p14:section name="Limits and purpose" id="{e61b516f-6500-a726-e851-35517faad081}">
+        <p14:section name="Limits and purpose" id="{c13a9433-7e76-b9e7-d3db-b75269aa1aa5}">
           <p14:sldIdLst>
             <p14:sldId id="263"/>
             <p14:sldId id="264"/>
@@ -550,7 +550,8 @@
           <a:p>
             <a:r>
               <a:rPr lang="en-US" dirty="0"/>
-              <a:t>This is a short, non-technical tour of a simulation project. The picture is a real result: air flowing from left to right past a round pole, seen from above. The red and blue blobs are swirls of air spinning in opposite directions.</a:t>
+              <a:t>I'd like to show you a computer simulation I did. This is the result: air flowing left to right past a round pole, seen from above. Red and blue are swirls of air spinning opposite ways.
+[If asked about wind direction:] Left to right, a steady 10 m/s, no gusts.</a:t>
             </a:r>
             <a:endParaRPr lang="en-US" dirty="0"/>
           </a:p>
@@ -638,7 +639,7 @@
           <a:p>
             <a:r>
               <a:rPr lang="en-US" dirty="0"/>
-              <a:t>Two takeaways. First, the practical one: engineers need these forces and this rhythm to design structures that stand up to wind and do not start vibrating. Second, the general one: a computer simulation is only as good as the checks behind it. Ask the same question with finer and finer detail until the answer stops changing, and then compare it with real measurements.</a:t>
+              <a:t>Two takeaways: engineers use numbers like these to keep structures safe from wind-induced vibration, and any simulation should be checked like this before you trust it. Happy to take your questions.</a:t>
             </a:r>
             <a:endParaRPr lang="en-US" dirty="0"/>
           </a:p>
@@ -726,7 +727,8 @@
           <a:p>
             <a:r>
               <a:rPr lang="en-US" dirty="0"/>
-              <a:t>Round shapes are everywhere: lamp posts, chimneys, bridge cables, offshore pipes. Wind does two things to them. It pushes them backwards, and it sheds swirls that shake them side to side. The second one is the sneaky one: a steady rhythm of small pushes, like pushing a child on a swing at the right moment, can build up large vibrations.</a:t>
+              <a:t>Wind does two things to a round pole: it pushes it back, and it sheds swirls that tug it side to side. The tugs are small but rhythmic, like pushing a swing at the right moment, so they can build up into large vibrations.
+[If asked about the pole's natural frequency:] Not in this model: the pole is rigid and fixed. The simulation gives the swirl rhythm; the pole's own rhythm depends on its height, material and fixing.</a:t>
             </a:r>
             <a:endParaRPr lang="en-US" dirty="0"/>
           </a:p>
@@ -814,7 +816,7 @@
           <a:p>
             <a:r>
               <a:rPr lang="en-US" dirty="0"/>
-              <a:t>A computer cannot solve air flow everywhere at once, so it divides the space around the pole into many small cells and solves the equations of air motion cell by cell, in tiny time steps. The sketch shows the idea: cells are thinnest right against the pole, where the air changes fastest, and grow larger farther away. (The real grid is rectangular farther out; this is a simplified drawing.)</a:t>
+              <a:t>The computer splits the air into up to 38,000 small cells and solves the equations of air motion in each one, 20,000 times per simulated second. The cells are smallest next to the pole, where the air changes fastest. It runs on free software, OpenFOAM, on my laptop.</a:t>
             </a:r>
             <a:endParaRPr lang="en-US" dirty="0"/>
           </a:p>
@@ -902,7 +904,8 @@
           <a:p>
             <a:r>
               <a:rPr lang="en-US" dirty="0"/>
-              <a:t>This pattern is famous enough to have a name: a von Karman vortex street. You can see it in clouds behind islands, and feel it when a flag flaps. Each swirl that breaks off gives the pole a small sideways tug, first one way, then the other. One full back-and-forth, a pair of swirls, happens about 25 times every second.</a:t>
+              <a:t>This is called a von Karman vortex street; you see it in clouds behind islands and in a flapping flag. Each swirl tugs the pole sideways. One full back-and-forth happens about 25 times a second.
+[If asked about the colours:] Red spins anticlockwise, blue clockwise; the stronger the colour, the faster the spin.</a:t>
             </a:r>
             <a:endParaRPr lang="en-US" dirty="0"/>
           </a:p>
@@ -990,7 +993,7 @@
           <a:p>
             <a:r>
               <a:rPr lang="en-US" dirty="0"/>
-              <a:t>Here are the results in everyday units. The steady push is about 6 newtons on every metre of pole, roughly the weight of a 600 gram bag of sugar. The sideways tug is about as strong, but it swings smoothly back and forth, 25 full swings every second. For a tall, thin structure, that rhythm matters more than the strength.</a:t>
+              <a:t>Per metre of pole: a steady push of 6 newtons, about the weight of a 600 g bag of sugar, and a sideways tug of about the same size, swinging back and forth 25 times a second. For tall, thin structures, the rhythm matters more than the size.</a:t>
             </a:r>
             <a:endParaRPr lang="en-US" dirty="0"/>
           </a:p>
@@ -1078,7 +1081,7 @@
           <a:p>
             <a:r>
               <a:rPr lang="en-US" dirty="0"/>
-              <a:t>This is the heart of the project. A computer answer depends on how finely you chop up the space. So the whole simulation was run three times, each time with smaller cells. The answers moved a little from coarse to medium, and much less from medium to fine: they are settling down. The same check was done for the size of the time steps. This checking step is called verification.</a:t>
+              <a:t>How do I know the computer is right? I ran it three times with smaller and smaller cells. From medium to fine, every answer changed by less than 2 %, and the time-step test agreed. That check is called verification.</a:t>
             </a:r>
             <a:endParaRPr lang="en-US" dirty="0"/>
           </a:p>
@@ -1166,7 +1169,7 @@
           <a:p>
             <a:r>
               <a:rPr lang="en-US" dirty="0"/>
-              <a:t>Combining the grid test and the time-step test gives an error band for each answer. For the push it is less than half a percent; for the rhythm of the swirls, under two percent. That does not yet mean the answer matches reality; it means the computer solved its equations accurately. Whether those equations describe real air well enough is the next question.</a:t>
+              <a:t>So the computer's own error is about half a percent on the push and under 2 % on the rhythm. That means the equations are solved accurately, not yet that they match real air.</a:t>
             </a:r>
             <a:endParaRPr lang="en-US" dirty="0"/>
           </a:p>
@@ -1254,7 +1257,7 @@
           <a:p>
             <a:r>
               <a:rPr lang="en-US" dirty="0"/>
-              <a:t>It is important to be honest about what this shows. Verification means the computer solved its equations correctly. Validation means checking those equations against the real world, with measurements from wind tunnels. That comparison has not been done yet; it is future work. The simulation also makes simplifications: it models a thin slice of the pole rather than the whole thing, and it approximates the small-scale turbulence. Only the comparison with measurements can show how much these matter.</a:t>
+              <a:t>Verification is done. Validation, comparing with wind-tunnel measurements, is not. The model is also simplified: a 2-D slice and approximate turbulence. Only measurements can show how much that matters.</a:t>
             </a:r>
             <a:endParaRPr lang="en-US" dirty="0"/>
           </a:p>
@@ -1342,7 +1345,7 @@
           <a:p>
             <a:r>
               <a:rPr lang="en-US" dirty="0"/>
-              <a:t>This project stops at checking the computer. Three steps would take it further. First, compare with wind-tunnel measurements, to see how close the answers are to real air. Second, take a real pole. Every structure has its own natural swing rhythm, set by its height, its material and how it is fixed. Once we know that rhythm, we can work out at which wind speeds the swirls would match it. Third, let the pole move in the simulation, to see how far it would actually shake. Beyond that: a full 3-D model, other turbulence models, and more wind speeds.</a:t>
+              <a:t>Next steps: compare with wind-tunnel data; take a real pole and find the wind speeds where its own rhythm matches the swirls; and let the pole move in the simulation to see how much it shakes.</a:t>
             </a:r>
             <a:endParaRPr lang="en-US" dirty="0"/>
           </a:p>
@@ -2184,7 +2187,7 @@
       </p:sp>
       <p:pic>
         <p:nvPicPr>
-          <p:cNvPr id="5" name="Vortex strip" descr="Simulated air flow behind a cylinder: red and blue swirls peel off alternately and drift downstream">    </p:cNvPr>
+          <p:cNvPr id="5" name="Vortex animation" descr="Simulated air flow behind a cylinder: red and blue swirls peel off alternately and drift downstream">    </p:cNvPr>
           <p:cNvPicPr>
             <a:picLocks noChangeAspect="1"/>
           </p:cNvPicPr>
@@ -2198,8 +2201,8 @@
         </p:blipFill>
         <p:spPr>
           <a:xfrm>
-            <a:off x="548640" y="2514600"/>
-            <a:ext cx="8046720" cy="2306726"/>
+            <a:off x="548640" y="2487168"/>
+            <a:ext cx="6744511" cy="2377440"/>
           </a:xfrm>
           <a:prstGeom prst="rect">
             <a:avLst/>

</xml_diff>

<commit_message>
docs(report): update the presentation to the verification-only scope
Slide 8 calls validation future work, new slide 9 lists the next steps, the sideways tug is 25 full swings a second, and the notes no longer claim the forces are too large. README: 10 slides. No change to D, U, nu, mesh counts or time steps.

Co-Authored-By: Claude Opus 5.5 <noreply@anthropic.com>
</commit_message>
<xml_diff>
--- a/report/presentation.pptx
+++ b/report/presentation.pptx
@@ -14,9 +14,10 @@
     <p:sldId id="262" r:id="rId8"/>
     <p:sldId id="263" r:id="rId9"/>
     <p:sldId id="264" r:id="rId10"/>
+    <p:sldId id="265" r:id="rId11"/>
   </p:sldIdLst>
   <p:notesMasterIdLst>
-    <p:notesMasterId r:id="rId11"/>
+    <p:notesMasterId r:id="rId12"/>
   </p:notesMasterIdLst>
   <p:sldSz cx="9144000" cy="5143500"/>
   <p:notesSz cx="5143500" cy="9144000"/>
@@ -115,33 +116,34 @@
   <p:extLst>
     <p:ext uri="{521415D9-36F7-43E2-AB2F-B90AF26B5E84}">
       <p14:sectionLst xmlns:p14="http://schemas.microsoft.com/office/powerpoint/2010/main">
-        <p14:section name="Introduction" id="{eb7cdbcb-aff7-feeb-be69-e06ce696667c}">
+        <p14:section name="Introduction" id="{c678cc22-c1c0-e9e3-e493-96f08861908e}">
           <p14:sldIdLst>
             <p14:sldId id="256"/>
             <p14:sldId id="257"/>
           </p14:sldIdLst>
         </p14:section>
-        <p14:section name="What was done" id="{a46ce174-e6b1-96ae-f9fd-568896a99543}">
+        <p14:section name="What was done" id="{f232c134-7dde-e1f6-dc8f-f2a205399830}">
           <p14:sldIdLst>
             <p14:sldId id="258"/>
           </p14:sldIdLst>
         </p14:section>
-        <p14:section name="Results" id="{9c13d889-7b31-2c35-65a8-b2da49bf8cee}">
+        <p14:section name="Results" id="{067d8ed1-ad3c-3db4-f977-06ec0f254712}">
           <p14:sldIdLst>
             <p14:sldId id="259"/>
             <p14:sldId id="260"/>
           </p14:sldIdLst>
         </p14:section>
-        <p14:section name="Can we trust it" id="{4a02fb93-93c4-f3c5-2ddc-ab001fe920f1}">
+        <p14:section name="Can we trust it" id="{ec082147-de56-231f-6816-bbf15877d702}">
           <p14:sldIdLst>
             <p14:sldId id="261"/>
             <p14:sldId id="262"/>
           </p14:sldIdLst>
         </p14:section>
-        <p14:section name="Limits and purpose" id="{704f78be-bb41-ca61-99f5-29402c0b0681}">
+        <p14:section name="Limits and purpose" id="{e61b516f-6500-a726-e851-35517faad081}">
           <p14:sldIdLst>
             <p14:sldId id="263"/>
             <p14:sldId id="264"/>
+            <p14:sldId id="265"/>
           </p14:sldIdLst>
         </p14:section>
       </p14:sectionLst>
@@ -590,6 +592,94 @@
 </p:notes>
 </file>
 
+<file path=ppt/notesSlides/notesSlide10.xml><?xml version="1.0" encoding="utf-8"?>
+<p:notes xmlns:a="http://schemas.openxmlformats.org/drawingml/2006/main" xmlns:r="http://schemas.openxmlformats.org/officeDocument/2006/relationships" xmlns:p="http://schemas.openxmlformats.org/presentationml/2006/main">
+  <p:cSld>
+    <p:spTree>
+      <p:nvGrpSpPr>
+        <p:cNvPr id="1" name=""/>
+        <p:cNvGrpSpPr/>
+        <p:nvPr/>
+      </p:nvGrpSpPr>
+      <p:grpSpPr>
+        <a:xfrm>
+          <a:off x="0" y="0"/>
+          <a:ext cx="0" cy="0"/>
+          <a:chOff x="0" y="0"/>
+          <a:chExt cx="0" cy="0"/>
+        </a:xfrm>
+      </p:grpSpPr>
+      <p:sp>
+        <p:nvSpPr>
+          <p:cNvPr id="2" name="Slide Image Placeholder 1"/>
+          <p:cNvSpPr>
+            <a:spLocks noGrp="1" noRot="1" noChangeAspect="1"/>
+          </p:cNvSpPr>
+          <p:nvPr>
+            <p:ph type="sldImg"/>
+          </p:nvPr>
+        </p:nvSpPr>
+        <p:spPr/>
+      </p:sp>
+      <p:sp>
+        <p:nvSpPr>
+          <p:cNvPr id="3" name="Notes Placeholder 2"/>
+          <p:cNvSpPr>
+            <a:spLocks noGrp="1"/>
+          </p:cNvSpPr>
+          <p:nvPr>
+            <p:ph type="body" idx="1"/>
+          </p:nvPr>
+        </p:nvSpPr>
+        <p:spPr/>
+        <p:txBody>
+          <a:bodyPr/>
+          <a:lstStyle/>
+          <a:p>
+            <a:r>
+              <a:rPr lang="en-US" dirty="0"/>
+              <a:t>Two takeaways. First, the practical one: engineers need these forces and this rhythm to design structures that stand up to wind and do not start vibrating. Second, the general one: a computer simulation is only as good as the checks behind it. Ask the same question with finer and finer detail until the answer stops changing, and then compare it with real measurements.</a:t>
+            </a:r>
+            <a:endParaRPr lang="en-US" dirty="0"/>
+          </a:p>
+        </p:txBody>
+      </p:sp>
+      <p:sp>
+        <p:nvSpPr>
+          <p:cNvPr id="4" name="Slide Number Placeholder 3"/>
+          <p:cNvSpPr>
+            <a:spLocks noGrp="1"/>
+          </p:cNvSpPr>
+          <p:nvPr>
+            <p:ph type="sldNum" sz="quarter" idx="10"/>
+          </p:nvPr>
+        </p:nvSpPr>
+        <p:spPr/>
+        <p:txBody>
+          <a:bodyPr/>
+          <a:lstStyle/>
+          <a:p>
+            <a:fld id="{F7021451-1387-4CA6-816F-3879F97B5CBC}" type="slidenum">
+              <a:rPr lang="en-US"/>
+              <a:t>10</a:t>
+            </a:fld>
+            <a:endParaRPr lang="en-US"/>
+          </a:p>
+        </p:txBody>
+      </p:sp>
+    </p:spTree>
+    <p:extLst>
+      <p:ext uri="{BB962C8B-B14F-4D97-AF65-F5344CB8AC3E}">
+        <p14:creationId xmlns:p14="http://schemas.microsoft.com/office/powerpoint/2010/main" val="1024086991"/>
+      </p:ext>
+    </p:extLst>
+  </p:cSld>
+  <p:clrMapOvr>
+    <a:masterClrMapping/>
+  </p:clrMapOvr>
+</p:notes>
+</file>
+
 <file path=ppt/notesSlides/notesSlide2.xml><?xml version="1.0" encoding="utf-8"?>
 <p:notes xmlns:a="http://schemas.openxmlformats.org/drawingml/2006/main" xmlns:r="http://schemas.openxmlformats.org/officeDocument/2006/relationships" xmlns:p="http://schemas.openxmlformats.org/presentationml/2006/main">
   <p:cSld>
@@ -812,7 +902,7 @@
           <a:p>
             <a:r>
               <a:rPr lang="en-US" dirty="0"/>
-              <a:t>This pattern is famous enough to have a name: a von Karman vortex street. You can see it in clouds behind islands, and feel it when a flag flaps. Each swirl that breaks off gives the pole a small sideways tug, first one way, then the other. In this case that happens about 25 times every second.</a:t>
+              <a:t>This pattern is famous enough to have a name: a von Karman vortex street. You can see it in clouds behind islands, and feel it when a flag flaps. Each swirl that breaks off gives the pole a small sideways tug, first one way, then the other. One full back-and-forth, a pair of swirls, happens about 25 times every second.</a:t>
             </a:r>
             <a:endParaRPr lang="en-US" dirty="0"/>
           </a:p>
@@ -900,7 +990,7 @@
           <a:p>
             <a:r>
               <a:rPr lang="en-US" dirty="0"/>
-              <a:t>Here are the results in everyday units. The steady push is about 6 newtons on every metre of pole, roughly the weight of a 600 gram bag of sugar. The sideways tug is about as strong, but it flips direction 25 times a second. For a tall, thin structure, that rhythm matters more than the strength.</a:t>
+              <a:t>Here are the results in everyday units. The steady push is about 6 newtons on every metre of pole, roughly the weight of a 600 gram bag of sugar. The sideways tug is about as strong, but it swings smoothly back and forth, 25 full swings every second. For a tall, thin structure, that rhythm matters more than the strength.</a:t>
             </a:r>
             <a:endParaRPr lang="en-US" dirty="0"/>
           </a:p>
@@ -1164,7 +1254,7 @@
           <a:p>
             <a:r>
               <a:rPr lang="en-US" dirty="0"/>
-              <a:t>It is important to be honest about what this shows. Verification means the computer solved its equations correctly. Validation means checking those equations against the real world, with measurements from wind tunnels. That comparison is the next step. The simulation also makes simplifications: it models a thin slice of the pole rather than the whole thing, and it approximates the small-scale turbulence. Those are expected to make the forces somewhat too large, and the comparison will tell by how much.</a:t>
+              <a:t>It is important to be honest about what this shows. Verification means the computer solved its equations correctly. Validation means checking those equations against the real world, with measurements from wind tunnels. That comparison has not been done yet; it is future work. The simulation also makes simplifications: it models a thin slice of the pole rather than the whole thing, and it approximates the small-scale turbulence. Only the comparison with measurements can show how much these matter.</a:t>
             </a:r>
             <a:endParaRPr lang="en-US" dirty="0"/>
           </a:p>
@@ -1252,7 +1342,7 @@
           <a:p>
             <a:r>
               <a:rPr lang="en-US" dirty="0"/>
-              <a:t>Two takeaways. First, the practical one: engineers need these forces and this rhythm to design structures that stand up to wind and do not start vibrating. Second, the general one: a computer simulation is only as good as the checks behind it. Ask the same question with finer and finer detail until the answer stops changing, and then compare it with real measurements.</a:t>
+              <a:t>This project stops at checking the computer. Three steps would take it further. First, compare with wind-tunnel measurements, to see how close the answers are to real air. Second, take a real pole. Every structure has its own natural swing rhythm, set by its height, its material and how it is fixed. Once we know that rhythm, we can work out at which wind speeds the swirls would match it. Third, let the pole move in the simulation, to see how far it would actually shake. Beyond that: a full 3-D model, other turbulence models, and more wind speeds.</a:t>
             </a:r>
             <a:endParaRPr lang="en-US" dirty="0"/>
           </a:p>
@@ -2199,6 +2289,298 @@
 </p:sld>
 </file>
 
+<file path=ppt/slides/slide10.xml><?xml version="1.0" encoding="utf-8"?>
+<p:sld xmlns:a="http://schemas.openxmlformats.org/drawingml/2006/main" xmlns:r="http://schemas.openxmlformats.org/officeDocument/2006/relationships" xmlns:p="http://schemas.openxmlformats.org/presentationml/2006/main">
+  <p:cSld name="Slide 10">
+    <p:spTree>
+      <p:nvGrpSpPr>
+        <p:cNvPr id="1" name=""/>
+        <p:cNvGrpSpPr/>
+        <p:nvPr/>
+      </p:nvGrpSpPr>
+      <p:grpSpPr>
+        <a:xfrm>
+          <a:off x="0" y="0"/>
+          <a:ext cx="0" cy="0"/>
+          <a:chOff x="0" y="0"/>
+          <a:chExt cx="0" cy="0"/>
+        </a:xfrm>
+      </p:grpSpPr>
+      <p:sp>
+        <p:nvSpPr>
+          <p:cNvPr id="2" name="Text 0"/>
+          <p:cNvSpPr/>
+          <p:nvPr>
+            <p:ph idx="100" type="title" hasCustomPrompt="1"/>
+          </p:nvPr>
+        </p:nvSpPr>
+        <p:spPr>
+          <a:xfrm>
+            <a:off x="548640" y="411480"/>
+            <a:ext cx="8046720" cy="731520"/>
+          </a:xfrm>
+          <a:prstGeom prst="rect">
+            <a:avLst/>
+          </a:prstGeom>
+          <a:noFill/>
+          <a:ln/>
+        </p:spPr>
+        <p:txBody>
+          <a:bodyPr wrap="square" lIns="0" tIns="0" rIns="0" bIns="0" rtlCol="0" anchor="t"/>
+          <a:lstStyle/>
+          <a:p>
+            <a:pPr algn="l" indent="0" marL="0">
+              <a:buNone/>
+            </a:pPr>
+            <a:r>
+              <a:rPr lang="en-US" sz="3000" b="1" dirty="0">
+                <a:solidFill>
+                  <a:schemeClr val="bg1"/>
+                </a:solidFill>
+                <a:latin typeface="+mj-lt" pitchFamily="34" charset="0"/>
+                <a:ea typeface="+mj-lt" pitchFamily="34" charset="-122"/>
+                <a:cs typeface="+mj-lt" pitchFamily="34" charset="-120"/>
+              </a:rPr>
+              <a:t>What it is for</a:t>
+            </a:r>
+            <a:endParaRPr lang="en-US" sz="3000" dirty="0"/>
+          </a:p>
+        </p:txBody>
+      </p:sp>
+      <p:pic>
+        <p:nvPicPr>
+          <p:cNvPr id="3" name="Icon Safer structures." descr="preencoded.png">    </p:cNvPr>
+          <p:cNvPicPr>
+            <a:picLocks noChangeAspect="1"/>
+          </p:cNvPicPr>
+          <p:nvPr/>
+        </p:nvPicPr>
+        <p:blipFill>
+          <a:blip r:embed="rId1"/>
+          <a:stretch>
+            <a:fillRect/>
+          </a:stretch>
+        </p:blipFill>
+        <p:spPr>
+          <a:xfrm>
+            <a:off x="548640" y="1417320"/>
+            <a:ext cx="502920" cy="502920"/>
+          </a:xfrm>
+          <a:prstGeom prst="rect">
+            <a:avLst/>
+          </a:prstGeom>
+        </p:spPr>
+      </p:pic>
+      <p:sp>
+        <p:nvSpPr>
+          <p:cNvPr id="4" name="Point 1"/>
+          <p:cNvSpPr txBox="1"/>
+          <p:nvPr/>
+        </p:nvSpPr>
+        <p:spPr>
+          <a:xfrm>
+            <a:off x="1325880" y="1280160"/>
+            <a:ext cx="7269480" cy="960120"/>
+          </a:xfrm>
+          <a:prstGeom prst="rect">
+            <a:avLst/>
+          </a:prstGeom>
+          <a:noFill/>
+          <a:ln/>
+        </p:spPr>
+        <p:txBody>
+          <a:bodyPr wrap="square" lIns="0" tIns="0" rIns="0" bIns="0" rtlCol="0" anchor="ctr"/>
+          <a:lstStyle/>
+          <a:p>
+            <a:pPr indent="0" marL="0">
+              <a:buNone/>
+            </a:pPr>
+            <a:r>
+              <a:rPr lang="en-US" sz="1800" b="1" dirty="0">
+                <a:solidFill>
+                  <a:schemeClr val="bg1"/>
+                </a:solidFill>
+              </a:rPr>
+              <a:t>Safer structures. </a:t>
+            </a:r>
+            <a:pPr indent="0" marL="0">
+              <a:buNone/>
+            </a:pPr>
+            <a:r>
+              <a:rPr lang="en-US" sz="1800" dirty="0">
+                <a:solidFill>
+                  <a:schemeClr val="bg1"/>
+                </a:solidFill>
+              </a:rPr>
+              <a:t>Engineers use numbers like these to size poles, chimneys and cables, and to keep their natural sway away from the rhythm of the swirls.</a:t>
+            </a:r>
+            <a:endParaRPr lang="en-US" sz="1800" dirty="0"/>
+          </a:p>
+        </p:txBody>
+      </p:sp>
+      <p:pic>
+        <p:nvPicPr>
+          <p:cNvPr id="5" name="Icon A habit worth having." descr="preencoded.png">    </p:cNvPr>
+          <p:cNvPicPr>
+            <a:picLocks noChangeAspect="1"/>
+          </p:cNvPicPr>
+          <p:nvPr/>
+        </p:nvPicPr>
+        <p:blipFill>
+          <a:blip r:embed="rId2"/>
+          <a:stretch>
+            <a:fillRect/>
+          </a:stretch>
+        </p:blipFill>
+        <p:spPr>
+          <a:xfrm>
+            <a:off x="548640" y="2606040"/>
+            <a:ext cx="502920" cy="502920"/>
+          </a:xfrm>
+          <a:prstGeom prst="rect">
+            <a:avLst/>
+          </a:prstGeom>
+        </p:spPr>
+      </p:pic>
+      <p:sp>
+        <p:nvSpPr>
+          <p:cNvPr id="6" name="Point 2"/>
+          <p:cNvSpPr txBox="1"/>
+          <p:nvPr/>
+        </p:nvSpPr>
+        <p:spPr>
+          <a:xfrm>
+            <a:off x="1325880" y="2468880"/>
+            <a:ext cx="7269480" cy="960120"/>
+          </a:xfrm>
+          <a:prstGeom prst="rect">
+            <a:avLst/>
+          </a:prstGeom>
+          <a:noFill/>
+          <a:ln/>
+        </p:spPr>
+        <p:txBody>
+          <a:bodyPr wrap="square" lIns="0" tIns="0" rIns="0" bIns="0" rtlCol="0" anchor="ctr"/>
+          <a:lstStyle/>
+          <a:p>
+            <a:pPr indent="0" marL="0">
+              <a:buNone/>
+            </a:pPr>
+            <a:r>
+              <a:rPr lang="en-US" sz="1800" b="1" dirty="0">
+                <a:solidFill>
+                  <a:schemeClr val="bg1"/>
+                </a:solidFill>
+              </a:rPr>
+              <a:t>A habit worth having. </a:t>
+            </a:r>
+            <a:pPr indent="0" marL="0">
+              <a:buNone/>
+            </a:pPr>
+            <a:r>
+              <a:rPr lang="en-US" sz="1800" dirty="0">
+                <a:solidFill>
+                  <a:schemeClr val="bg1"/>
+                </a:solidFill>
+              </a:rPr>
+              <a:t>Any simulation, of weather, cars or traffic, should be checked like this before its answer is trusted.</a:t>
+            </a:r>
+            <a:endParaRPr lang="en-US" sz="1800" dirty="0"/>
+          </a:p>
+        </p:txBody>
+      </p:sp>
+      <p:sp>
+        <p:nvSpPr>
+          <p:cNvPr id="7" name="Closing line"/>
+          <p:cNvSpPr txBox="1"/>
+          <p:nvPr/>
+        </p:nvSpPr>
+        <p:spPr>
+          <a:xfrm>
+            <a:off x="548640" y="3931920"/>
+            <a:ext cx="8046720" cy="457200"/>
+          </a:xfrm>
+          <a:prstGeom prst="rect">
+            <a:avLst/>
+          </a:prstGeom>
+          <a:noFill/>
+          <a:ln/>
+        </p:spPr>
+        <p:txBody>
+          <a:bodyPr wrap="square" lIns="0" tIns="0" rIns="0" bIns="0" rtlCol="0" anchor="t"/>
+          <a:lstStyle/>
+          <a:p>
+            <a:pPr indent="0" marL="0">
+              <a:buNone/>
+            </a:pPr>
+            <a:r>
+              <a:rPr lang="en-US" sz="2200" b="1" dirty="0">
+                <a:solidFill>
+                  <a:schemeClr val="accent3"/>
+                </a:solidFill>
+                <a:latin typeface="+mj-lt" pitchFamily="34" charset="0"/>
+                <a:ea typeface="+mj-lt" pitchFamily="34" charset="-122"/>
+                <a:cs typeface="+mj-lt" pitchFamily="34" charset="-120"/>
+              </a:rPr>
+              <a:t>Check the computer first; then check it against reality.</a:t>
+            </a:r>
+            <a:endParaRPr lang="en-US" sz="2200" dirty="0"/>
+          </a:p>
+        </p:txBody>
+      </p:sp>
+      <p:sp>
+        <p:nvSpPr>
+          <p:cNvPr id="25" name="Slide Number Placeholder 0"/>
+          <p:cNvSpPr>
+            <a:spLocks noGrp="1"/>
+          </p:cNvSpPr>
+          <p:nvPr>
+            <p:ph type="sldNum" sz="quarter" idx="4294967295"/>
+          </p:nvPr>
+        </p:nvSpPr>
+        <p:spPr>
+          <a:xfrm>
+            <a:off x="8412480" y="4754880"/>
+            <a:ext cx="457200" cy="274320"/>
+          </a:xfrm>
+          <a:prstGeom prst="rect">
+            <a:avLst/>
+          </a:prstGeom>
+          <a:extLst>
+            <a:ext uri="{C572A759-6A51-4108-AA02-DFA0A04FC94B}">
+              <ma14:wrappingTextBoxFlag xmlns:ma14="http://schemas.microsoft.com/office/mac/drawingml/2011/main" val="0"/>
+            </a:ext>
+          </a:extLst>
+        </p:spPr>
+        <p:txBody>
+          <a:bodyPr/>
+          <a:lstStyle>
+            <a:lvl1pPr>
+              <a:defRPr sz="1000">
+                <a:solidFill>
+                  <a:schemeClr val="accent6"/>
+                </a:solidFill>
+              </a:defRPr>
+            </a:lvl1pPr>
+          </a:lstStyle>
+          <a:p>
+            <a:pPr algn="r"/>
+            <a:fld id="{F7021451-1387-4CA6-816F-3879F97B5CBC}" type="slidenum">
+              <a:rPr b="0" lang="en-US"/>
+              <a:t>10</a:t>
+            </a:fld>
+            <a:endParaRPr lang="en-US"/>
+          </a:p>
+        </p:txBody>
+      </p:sp>
+    </p:spTree>
+  </p:cSld>
+  <p:clrMapOvr>
+    <a:masterClrMapping/>
+  </p:clrMapOvr>
+</p:sld>
+</file>
+
 <file path=ppt/slides/slide2.xml><?xml version="1.0" encoding="utf-8"?>
 <p:sld xmlns:a="http://schemas.openxmlformats.org/drawingml/2006/main" xmlns:r="http://schemas.openxmlformats.org/officeDocument/2006/relationships" xmlns:p="http://schemas.openxmlformats.org/presentationml/2006/main">
   <p:cSld name="Slide 2">
@@ -3094,7 +3476,7 @@
                   <a:schemeClr val="accent6"/>
                 </a:solidFill>
               </a:rPr>
-              <a:t>They break off top, then bottom, about 25 times a second.</a:t>
+              <a:t>A pair, one top and one bottom, breaks off about 25 times a second.</a:t>
             </a:r>
             <a:endParaRPr lang="en-US" sz="1800" dirty="0"/>
           </a:p>
@@ -3535,7 +3917,7 @@
                   <a:schemeClr val="tx2"/>
                 </a:solidFill>
               </a:rPr>
-              <a:t>changing direction 25 times a second, as each swirl breaks off</a:t>
+              <a:t>swinging smoothly back and forth, 25 full swings a second, one for each pair of swirls</a:t>
             </a:r>
             <a:endParaRPr lang="en-US" sz="1500" dirty="0"/>
           </a:p>
@@ -5324,7 +5706,7 @@
       </p:sp>
       <p:sp>
         <p:nvSpPr>
-          <p:cNvPr id="7" name="Card Next: validation"/>
+          <p:cNvPr id="7" name="Card Not yet: validation"/>
           <p:cNvSpPr/>
           <p:nvPr/>
         </p:nvSpPr>
@@ -5351,7 +5733,7 @@
       </p:sp>
       <p:pic>
         <p:nvPicPr>
-          <p:cNvPr id="8" name="Icon Next: validation" descr="preencoded.png">    </p:cNvPr>
+          <p:cNvPr id="8" name="Icon Not yet: validation" descr="preencoded.png">    </p:cNvPr>
           <p:cNvPicPr>
             <a:picLocks noChangeAspect="1"/>
           </p:cNvPicPr>
@@ -5406,7 +5788,7 @@
                 <a:ea typeface="+mj-lt" pitchFamily="34" charset="-122"/>
                 <a:cs typeface="+mj-lt" pitchFamily="34" charset="-120"/>
               </a:rPr>
-              <a:t>Next: validation</a:t>
+              <a:t>Not yet: validation</a:t>
             </a:r>
             <a:endParaRPr lang="en-US" sz="2000" dirty="0"/>
           </a:p>
@@ -5445,7 +5827,7 @@
                   <a:schemeClr val="tx2"/>
                 </a:solidFill>
               </a:rPr>
-              <a:t>Compare with wind-tunnel measurements to see if the equations describe real air.</a:t>
+              <a:t>Comparing with wind-tunnel measurements, to see if the equations describe real air, is future work.</a:t>
             </a:r>
             <a:endParaRPr lang="en-US" sz="1500" dirty="0"/>
           </a:p>
@@ -5679,21 +6061,48 @@
             <a:r>
               <a:rPr lang="en-US" sz="3000" b="1" dirty="0">
                 <a:solidFill>
-                  <a:schemeClr val="bg1"/>
+                  <a:schemeClr val="tx1"/>
                 </a:solidFill>
                 <a:latin typeface="+mj-lt" pitchFamily="34" charset="0"/>
                 <a:ea typeface="+mj-lt" pitchFamily="34" charset="-122"/>
                 <a:cs typeface="+mj-lt" pitchFamily="34" charset="-120"/>
               </a:rPr>
-              <a:t>What it is for</a:t>
+              <a:t>What comes next</a:t>
             </a:r>
             <a:endParaRPr lang="en-US" sz="3000" dirty="0"/>
           </a:p>
         </p:txBody>
+      </p:sp>
+      <p:sp>
+        <p:nvSpPr>
+          <p:cNvPr id="3" name="Card Check against real air"/>
+          <p:cNvSpPr/>
+          <p:nvPr/>
+        </p:nvSpPr>
+        <p:spPr>
+          <a:xfrm>
+            <a:off x="548640" y="1325880"/>
+            <a:ext cx="2499360" cy="3017520"/>
+          </a:xfrm>
+          <a:prstGeom prst="roundRect">
+            <a:avLst>
+              <a:gd name="adj" fmla="val 4390"/>
+            </a:avLst>
+          </a:prstGeom>
+          <a:solidFill>
+            <a:schemeClr val="bg2"/>
+          </a:solidFill>
+          <a:ln w="12700">
+            <a:solidFill>
+              <a:srgbClr val="E4E1D8"/>
+            </a:solidFill>
+            <a:prstDash val="solid"/>
+          </a:ln>
+        </p:spPr>
       </p:sp>
       <p:pic>
         <p:nvPicPr>
-          <p:cNvPr id="3" name="Icon Safer structures." descr="preencoded.png">    </p:cNvPr>
+          <p:cNvPr id="4" name="Icon Check against real air" descr="preencoded.png">    </p:cNvPr>
           <p:cNvPicPr>
             <a:picLocks noChangeAspect="1"/>
           </p:cNvPicPr>
@@ -5707,8 +6116,8 @@
         </p:blipFill>
         <p:spPr>
           <a:xfrm>
-            <a:off x="548640" y="1417320"/>
-            <a:ext cx="502920" cy="502920"/>
+            <a:off x="822960" y="1600200"/>
+            <a:ext cx="457200" cy="457200"/>
           </a:xfrm>
           <a:prstGeom prst="rect">
             <a:avLst/>
@@ -5717,14 +6126,14 @@
       </p:pic>
       <p:sp>
         <p:nvSpPr>
-          <p:cNvPr id="4" name="Point 1"/>
+          <p:cNvPr id="5" name="Text 2"/>
           <p:cNvSpPr txBox="1"/>
           <p:nvPr/>
         </p:nvSpPr>
         <p:spPr>
           <a:xfrm>
-            <a:off x="1325880" y="1280160"/>
-            <a:ext cx="7269480" cy="960120"/>
+            <a:off x="822960" y="2240280"/>
+            <a:ext cx="1950720" cy="685800"/>
           </a:xfrm>
           <a:prstGeom prst="rect">
             <a:avLst/>
@@ -5733,38 +6142,96 @@
           <a:ln/>
         </p:spPr>
         <p:txBody>
-          <a:bodyPr wrap="square" lIns="0" tIns="0" rIns="0" bIns="0" rtlCol="0" anchor="ctr"/>
+          <a:bodyPr wrap="square" lIns="0" tIns="0" rIns="0" bIns="0" rtlCol="0" anchor="t"/>
           <a:lstStyle/>
           <a:p>
             <a:pPr indent="0" marL="0">
               <a:buNone/>
             </a:pPr>
             <a:r>
-              <a:rPr lang="en-US" sz="1800" b="1" dirty="0">
-                <a:solidFill>
-                  <a:schemeClr val="bg1"/>
-                </a:solidFill>
+              <a:rPr lang="en-US" sz="2000" b="1" dirty="0">
+                <a:solidFill>
+                  <a:schemeClr val="tx1"/>
+                </a:solidFill>
+                <a:latin typeface="+mj-lt" pitchFamily="34" charset="0"/>
+                <a:ea typeface="+mj-lt" pitchFamily="34" charset="-122"/>
+                <a:cs typeface="+mj-lt" pitchFamily="34" charset="-120"/>
               </a:rPr>
-              <a:t>Safer structures. </a:t>
-            </a:r>
+              <a:t>Check against real air</a:t>
+            </a:r>
+            <a:endParaRPr lang="en-US" sz="2000" dirty="0"/>
+          </a:p>
+        </p:txBody>
+      </p:sp>
+      <p:sp>
+        <p:nvSpPr>
+          <p:cNvPr id="6" name="Text 3"/>
+          <p:cNvSpPr txBox="1"/>
+          <p:nvPr/>
+        </p:nvSpPr>
+        <p:spPr>
+          <a:xfrm>
+            <a:off x="822960" y="2971800"/>
+            <a:ext cx="1950720" cy="1280160"/>
+          </a:xfrm>
+          <a:prstGeom prst="rect">
+            <a:avLst/>
+          </a:prstGeom>
+          <a:noFill/>
+          <a:ln/>
+        </p:spPr>
+        <p:txBody>
+          <a:bodyPr wrap="square" lIns="0" tIns="0" rIns="0" bIns="0" rtlCol="0" anchor="t"/>
+          <a:lstStyle/>
+          <a:p>
             <a:pPr indent="0" marL="0">
+              <a:lnSpc>
+                <a:spcPct val="110000"/>
+              </a:lnSpc>
               <a:buNone/>
             </a:pPr>
             <a:r>
-              <a:rPr lang="en-US" sz="1800" dirty="0">
-                <a:solidFill>
-                  <a:schemeClr val="bg1"/>
+              <a:rPr lang="en-US" sz="1500" dirty="0">
+                <a:solidFill>
+                  <a:schemeClr val="tx2"/>
                 </a:solidFill>
               </a:rPr>
-              <a:t>Engineers use numbers like these to size poles, chimneys and cables, and to keep their natural sway away from the rhythm of the swirls.</a:t>
-            </a:r>
-            <a:endParaRPr lang="en-US" sz="1800" dirty="0"/>
-          </a:p>
-        </p:txBody>
+              <a:t>Compare with wind-tunnel measurements, to learn how close the computer is to reality.</a:t>
+            </a:r>
+            <a:endParaRPr lang="en-US" sz="1500" dirty="0"/>
+          </a:p>
+        </p:txBody>
+      </p:sp>
+      <p:sp>
+        <p:nvSpPr>
+          <p:cNvPr id="7" name="Card Test a real pole"/>
+          <p:cNvSpPr/>
+          <p:nvPr/>
+        </p:nvSpPr>
+        <p:spPr>
+          <a:xfrm>
+            <a:off x="3322320" y="1325880"/>
+            <a:ext cx="2499360" cy="3017520"/>
+          </a:xfrm>
+          <a:prstGeom prst="roundRect">
+            <a:avLst>
+              <a:gd name="adj" fmla="val 4390"/>
+            </a:avLst>
+          </a:prstGeom>
+          <a:solidFill>
+            <a:schemeClr val="bg2"/>
+          </a:solidFill>
+          <a:ln w="12700">
+            <a:solidFill>
+              <a:srgbClr val="E4E1D8"/>
+            </a:solidFill>
+            <a:prstDash val="solid"/>
+          </a:ln>
+        </p:spPr>
       </p:sp>
       <p:pic>
         <p:nvPicPr>
-          <p:cNvPr id="5" name="Icon A habit worth having." descr="preencoded.png">    </p:cNvPr>
+          <p:cNvPr id="8" name="Icon Test a real pole" descr="preencoded.png">    </p:cNvPr>
           <p:cNvPicPr>
             <a:picLocks noChangeAspect="1"/>
           </p:cNvPicPr>
@@ -5778,8 +6245,8 @@
         </p:blipFill>
         <p:spPr>
           <a:xfrm>
-            <a:off x="548640" y="2606040"/>
-            <a:ext cx="502920" cy="502920"/>
+            <a:off x="3596640" y="1600200"/>
+            <a:ext cx="457200" cy="457200"/>
           </a:xfrm>
           <a:prstGeom prst="rect">
             <a:avLst/>
@@ -5788,14 +6255,14 @@
       </p:pic>
       <p:sp>
         <p:nvSpPr>
-          <p:cNvPr id="6" name="Point 2"/>
+          <p:cNvPr id="9" name="Text 5"/>
           <p:cNvSpPr txBox="1"/>
           <p:nvPr/>
         </p:nvSpPr>
         <p:spPr>
           <a:xfrm>
-            <a:off x="1325880" y="2468880"/>
-            <a:ext cx="7269480" cy="960120"/>
+            <a:off x="3596640" y="2240280"/>
+            <a:ext cx="1950720" cy="685800"/>
           </a:xfrm>
           <a:prstGeom prst="rect">
             <a:avLst/>
@@ -5804,71 +6271,228 @@
           <a:ln/>
         </p:spPr>
         <p:txBody>
-          <a:bodyPr wrap="square" lIns="0" tIns="0" rIns="0" bIns="0" rtlCol="0" anchor="ctr"/>
+          <a:bodyPr wrap="square" lIns="0" tIns="0" rIns="0" bIns="0" rtlCol="0" anchor="t"/>
           <a:lstStyle/>
           <a:p>
             <a:pPr indent="0" marL="0">
               <a:buNone/>
             </a:pPr>
             <a:r>
-              <a:rPr lang="en-US" sz="1800" b="1" dirty="0">
-                <a:solidFill>
-                  <a:schemeClr val="bg1"/>
-                </a:solidFill>
-              </a:rPr>
-              <a:t>A habit worth having. </a:t>
-            </a:r>
-            <a:pPr indent="0" marL="0">
-              <a:buNone/>
-            </a:pPr>
-            <a:r>
-              <a:rPr lang="en-US" sz="1800" dirty="0">
-                <a:solidFill>
-                  <a:schemeClr val="bg1"/>
-                </a:solidFill>
-              </a:rPr>
-              <a:t>Any simulation, of weather, cars or traffic, should be checked like this before its answer is trusted.</a:t>
-            </a:r>
-            <a:endParaRPr lang="en-US" sz="1800" dirty="0"/>
-          </a:p>
-        </p:txBody>
-      </p:sp>
-      <p:sp>
-        <p:nvSpPr>
-          <p:cNvPr id="7" name="Closing line"/>
-          <p:cNvSpPr txBox="1"/>
-          <p:nvPr/>
-        </p:nvSpPr>
-        <p:spPr>
-          <a:xfrm>
-            <a:off x="548640" y="3931920"/>
-            <a:ext cx="8046720" cy="457200"/>
-          </a:xfrm>
-          <a:prstGeom prst="rect">
-            <a:avLst/>
-          </a:prstGeom>
-          <a:noFill/>
-          <a:ln/>
-        </p:spPr>
-        <p:txBody>
-          <a:bodyPr wrap="square" lIns="0" tIns="0" rIns="0" bIns="0" rtlCol="0" anchor="t"/>
-          <a:lstStyle/>
-          <a:p>
-            <a:pPr indent="0" marL="0">
-              <a:buNone/>
-            </a:pPr>
-            <a:r>
-              <a:rPr lang="en-US" sz="2200" b="1" dirty="0">
-                <a:solidFill>
-                  <a:schemeClr val="accent3"/>
+              <a:rPr lang="en-US" sz="2000" b="1" dirty="0">
+                <a:solidFill>
+                  <a:schemeClr val="tx1"/>
                 </a:solidFill>
                 <a:latin typeface="+mj-lt" pitchFamily="34" charset="0"/>
                 <a:ea typeface="+mj-lt" pitchFamily="34" charset="-122"/>
                 <a:cs typeface="+mj-lt" pitchFamily="34" charset="-120"/>
               </a:rPr>
-              <a:t>Check the computer first; then check it against reality.</a:t>
-            </a:r>
-            <a:endParaRPr lang="en-US" sz="2200" dirty="0"/>
+              <a:t>Test a real pole</a:t>
+            </a:r>
+            <a:endParaRPr lang="en-US" sz="2000" dirty="0"/>
+          </a:p>
+        </p:txBody>
+      </p:sp>
+      <p:sp>
+        <p:nvSpPr>
+          <p:cNvPr id="10" name="Text 6"/>
+          <p:cNvSpPr txBox="1"/>
+          <p:nvPr/>
+        </p:nvSpPr>
+        <p:spPr>
+          <a:xfrm>
+            <a:off x="3596640" y="2971800"/>
+            <a:ext cx="1950720" cy="1280160"/>
+          </a:xfrm>
+          <a:prstGeom prst="rect">
+            <a:avLst/>
+          </a:prstGeom>
+          <a:noFill/>
+          <a:ln/>
+        </p:spPr>
+        <p:txBody>
+          <a:bodyPr wrap="square" lIns="0" tIns="0" rIns="0" bIns="0" rtlCol="0" anchor="t"/>
+          <a:lstStyle/>
+          <a:p>
+            <a:pPr indent="0" marL="0">
+              <a:lnSpc>
+                <a:spcPct val="110000"/>
+              </a:lnSpc>
+              <a:buNone/>
+            </a:pPr>
+            <a:r>
+              <a:rPr lang="en-US" sz="1500" dirty="0">
+                <a:solidFill>
+                  <a:schemeClr val="tx2"/>
+                </a:solidFill>
+              </a:rPr>
+              <a:t>Find a real pole's own swing rhythm, and the wind speeds where the swirls match it.</a:t>
+            </a:r>
+            <a:endParaRPr lang="en-US" sz="1500" dirty="0"/>
+          </a:p>
+        </p:txBody>
+      </p:sp>
+      <p:sp>
+        <p:nvSpPr>
+          <p:cNvPr id="11" name="Card Let the pole move"/>
+          <p:cNvSpPr/>
+          <p:nvPr/>
+        </p:nvSpPr>
+        <p:spPr>
+          <a:xfrm>
+            <a:off x="6096000" y="1325880"/>
+            <a:ext cx="2499360" cy="3017520"/>
+          </a:xfrm>
+          <a:prstGeom prst="roundRect">
+            <a:avLst>
+              <a:gd name="adj" fmla="val 4390"/>
+            </a:avLst>
+          </a:prstGeom>
+          <a:solidFill>
+            <a:schemeClr val="bg2"/>
+          </a:solidFill>
+          <a:ln w="12700">
+            <a:solidFill>
+              <a:srgbClr val="E4E1D8"/>
+            </a:solidFill>
+            <a:prstDash val="solid"/>
+          </a:ln>
+        </p:spPr>
+      </p:sp>
+      <p:pic>
+        <p:nvPicPr>
+          <p:cNvPr id="12" name="Icon Let the pole move" descr="preencoded.png">    </p:cNvPr>
+          <p:cNvPicPr>
+            <a:picLocks noChangeAspect="1"/>
+          </p:cNvPicPr>
+          <p:nvPr/>
+        </p:nvPicPr>
+        <p:blipFill>
+          <a:blip r:embed="rId3"/>
+          <a:stretch>
+            <a:fillRect/>
+          </a:stretch>
+        </p:blipFill>
+        <p:spPr>
+          <a:xfrm>
+            <a:off x="6370320" y="1600200"/>
+            <a:ext cx="457200" cy="457200"/>
+          </a:xfrm>
+          <a:prstGeom prst="rect">
+            <a:avLst/>
+          </a:prstGeom>
+        </p:spPr>
+      </p:pic>
+      <p:sp>
+        <p:nvSpPr>
+          <p:cNvPr id="13" name="Text 8"/>
+          <p:cNvSpPr txBox="1"/>
+          <p:nvPr/>
+        </p:nvSpPr>
+        <p:spPr>
+          <a:xfrm>
+            <a:off x="6370320" y="2240280"/>
+            <a:ext cx="1950720" cy="685800"/>
+          </a:xfrm>
+          <a:prstGeom prst="rect">
+            <a:avLst/>
+          </a:prstGeom>
+          <a:noFill/>
+          <a:ln/>
+        </p:spPr>
+        <p:txBody>
+          <a:bodyPr wrap="square" lIns="0" tIns="0" rIns="0" bIns="0" rtlCol="0" anchor="t"/>
+          <a:lstStyle/>
+          <a:p>
+            <a:pPr indent="0" marL="0">
+              <a:buNone/>
+            </a:pPr>
+            <a:r>
+              <a:rPr lang="en-US" sz="2000" b="1" dirty="0">
+                <a:solidFill>
+                  <a:schemeClr val="tx1"/>
+                </a:solidFill>
+                <a:latin typeface="+mj-lt" pitchFamily="34" charset="0"/>
+                <a:ea typeface="+mj-lt" pitchFamily="34" charset="-122"/>
+                <a:cs typeface="+mj-lt" pitchFamily="34" charset="-120"/>
+              </a:rPr>
+              <a:t>Let the pole move</a:t>
+            </a:r>
+            <a:endParaRPr lang="en-US" sz="2000" dirty="0"/>
+          </a:p>
+        </p:txBody>
+      </p:sp>
+      <p:sp>
+        <p:nvSpPr>
+          <p:cNvPr id="14" name="Text 9"/>
+          <p:cNvSpPr txBox="1"/>
+          <p:nvPr/>
+        </p:nvSpPr>
+        <p:spPr>
+          <a:xfrm>
+            <a:off x="6370320" y="2971800"/>
+            <a:ext cx="1950720" cy="1280160"/>
+          </a:xfrm>
+          <a:prstGeom prst="rect">
+            <a:avLst/>
+          </a:prstGeom>
+          <a:noFill/>
+          <a:ln/>
+        </p:spPr>
+        <p:txBody>
+          <a:bodyPr wrap="square" lIns="0" tIns="0" rIns="0" bIns="0" rtlCol="0" anchor="t"/>
+          <a:lstStyle/>
+          <a:p>
+            <a:pPr indent="0" marL="0">
+              <a:lnSpc>
+                <a:spcPct val="110000"/>
+              </a:lnSpc>
+              <a:buNone/>
+            </a:pPr>
+            <a:r>
+              <a:rPr lang="en-US" sz="1500" dirty="0">
+                <a:solidFill>
+                  <a:schemeClr val="tx2"/>
+                </a:solidFill>
+              </a:rPr>
+              <a:t>Simulate a pole that can sway, to see how far it would actually shake.</a:t>
+            </a:r>
+            <a:endParaRPr lang="en-US" sz="1500" dirty="0"/>
+          </a:p>
+        </p:txBody>
+      </p:sp>
+      <p:sp>
+        <p:nvSpPr>
+          <p:cNvPr id="15" name="Footnote"/>
+          <p:cNvSpPr txBox="1"/>
+          <p:nvPr/>
+        </p:nvSpPr>
+        <p:spPr>
+          <a:xfrm>
+            <a:off x="548640" y="4462272"/>
+            <a:ext cx="8046720" cy="274320"/>
+          </a:xfrm>
+          <a:prstGeom prst="rect">
+            <a:avLst/>
+          </a:prstGeom>
+          <a:noFill/>
+          <a:ln/>
+        </p:spPr>
+        <p:txBody>
+          <a:bodyPr wrap="square" lIns="0" tIns="0" rIns="0" bIns="0" rtlCol="0" anchor="t"/>
+          <a:lstStyle/>
+          <a:p>
+            <a:pPr indent="0" marL="0">
+              <a:buNone/>
+            </a:pPr>
+            <a:r>
+              <a:rPr lang="en-US" sz="1200" i="1" dirty="0">
+                <a:solidFill>
+                  <a:schemeClr val="accent5"/>
+                </a:solidFill>
+              </a:rPr>
+              <a:t>Also: a full 3-D pole, other turbulence models, and more wind speeds.</a:t>
+            </a:r>
+            <a:endParaRPr lang="en-US" sz="1200" dirty="0"/>
           </a:p>
         </p:txBody>
       </p:sp>
@@ -5902,7 +6526,7 @@
             <a:lvl1pPr>
               <a:defRPr sz="1000">
                 <a:solidFill>
-                  <a:schemeClr val="accent6"/>
+                  <a:schemeClr val="accent5"/>
                 </a:solidFill>
               </a:defRPr>
             </a:lvl1pPr>

</xml_diff>

<commit_message>
docs: add MIT license and use American spelling
No change to D, U, nu, mesh counts or time steps.

Co-Authored-By: Claude Opus 5.5 <noreply@anthropic.com>
</commit_message>
<xml_diff>
--- a/report/presentation.pptx
+++ b/report/presentation.pptx
@@ -116,30 +116,30 @@
   <p:extLst>
     <p:ext uri="{521415D9-36F7-43E2-AB2F-B90AF26B5E84}">
       <p14:sectionLst xmlns:p14="http://schemas.microsoft.com/office/powerpoint/2010/main">
-        <p14:section name="Introduction" id="{55144bba-e0f8-c9e2-e020-71ff0b4934ed}">
+        <p14:section name="Introduction" id="{7f0db5f7-6681-6543-8ca3-1f0d330f22d0}">
           <p14:sldIdLst>
             <p14:sldId id="256"/>
             <p14:sldId id="257"/>
           </p14:sldIdLst>
         </p14:section>
-        <p14:section name="What was done" id="{9a357aaa-68b4-ca1b-5d7d-7a8458dff4c3}">
+        <p14:section name="What was done" id="{8d6cd9d4-1a1f-323c-9b98-a553cd2b546c}">
           <p14:sldIdLst>
             <p14:sldId id="258"/>
           </p14:sldIdLst>
         </p14:section>
-        <p14:section name="Results" id="{ed899025-ed04-ddab-61ec-b0ebcb7c396b}">
+        <p14:section name="Results" id="{a35880a5-a0bc-b52c-74f6-b2027fcf8133}">
           <p14:sldIdLst>
             <p14:sldId id="259"/>
             <p14:sldId id="260"/>
           </p14:sldIdLst>
         </p14:section>
-        <p14:section name="Can we trust it" id="{c8a9abf8-6b0b-49b7-b796-5890d99694e8}">
+        <p14:section name="Can we trust it" id="{b63ab78c-d7f9-8c65-0f70-d59869baeda7}">
           <p14:sldIdLst>
             <p14:sldId id="261"/>
             <p14:sldId id="262"/>
           </p14:sldIdLst>
         </p14:section>
-        <p14:section name="Limits and purpose" id="{c13a9433-7e76-b9e7-d3db-b75269aa1aa5}">
+        <p14:section name="Limits and purpose" id="{cdd00c75-6bd8-9011-c352-3d7fdf43c39b}">
           <p14:sldIdLst>
             <p14:sldId id="263"/>
             <p14:sldId id="264"/>
@@ -905,7 +905,7 @@
             <a:r>
               <a:rPr lang="en-US" dirty="0"/>
               <a:t>This is called a von Karman vortex street; you see it in clouds behind islands and in a flapping flag. Each swirl tugs the pole sideways. One full back-and-forth happens about 25 times a second.
-[If asked about the colours:] Red spins anticlockwise, blue clockwise; the stronger the colour, the faster the spin.</a:t>
+[If asked about the colors:] Red spins counterclockwise, blue clockwise; the stronger the color, the faster the spin.</a:t>
             </a:r>
             <a:endParaRPr lang="en-US" dirty="0"/>
           </a:p>
@@ -993,7 +993,7 @@
           <a:p>
             <a:r>
               <a:rPr lang="en-US" dirty="0"/>
-              <a:t>Per metre of pole: a steady push of 6 newtons, about the weight of a 600 g bag of sugar, and a sideways tug of about the same size, swinging back and forth 25 times a second. For tall, thin structures, the rhythm matters more than the size.</a:t>
+              <a:t>Per meter of pole: a steady push of 6 newtons, about the weight of a 600 g bag of sugar, and a sideways tug of about the same size, swinging back and forth 25 times a second. For tall, thin structures, the rhythm matters more than the size.</a:t>
             </a:r>
             <a:endParaRPr lang="en-US" dirty="0"/>
           </a:p>
@@ -3590,7 +3590,7 @@
                 <a:ea typeface="+mj-lt" pitchFamily="34" charset="-122"/>
                 <a:cs typeface="+mj-lt" pitchFamily="34" charset="-120"/>
               </a:rPr>
-              <a:t>What the wind does to every metre of pole</a:t>
+              <a:t>What the wind does to every meter of pole</a:t>
             </a:r>
             <a:endParaRPr lang="en-US" sz="3000" dirty="0"/>
           </a:p>
@@ -3755,7 +3755,7 @@
                   <a:schemeClr val="tx2"/>
                 </a:solidFill>
               </a:rPr>
-              <a:t>steady, about the weight of a 600 g bag of sugar hanging from each metre</a:t>
+              <a:t>steady, about the weight of a 600 g bag of sugar hanging from each meter</a:t>
             </a:r>
             <a:endParaRPr lang="en-US" sz="1500" dirty="0"/>
           </a:p>

</xml_diff>